<commit_message>
Carry the team names into every document and the deck
The names came from the web edit: 김다빈 planning/UX, 김진아 development,
이승민 verification/docs. The README table had lost its commit column in that
edit, so it is restored alongside the names, and the same three rows now
appear in TEAM_ROLES, the result report and slides 1 and 12.

Co-Authored-By: Claude Opus 5 <noreply@anthropic.com>
Claude-Session: https://claude.ai/code/session_01Q3547CZe5AwKq73dkBk4s7
</commit_message>
<xml_diff>
--- a/docs/presentation.pptx
+++ b/docs/presentation.pptx
@@ -2031,7 +2031,7 @@
                 <a:ea typeface="Malgun Gothic" pitchFamily="34" charset="-122"/>
                 <a:cs typeface="Malgun Gothic" pitchFamily="34" charset="-120"/>
               </a:rPr>
-              <a:t>팀명 ______ · 팀원 3인 (기획/UX · 개발 · 검증/문서)</a:t>
+              <a:t>팀원 3인 · 김다빈(기획/UX) · 김진아(개발) · 이승민(검증/문서)</a:t>
             </a:r>
             <a:endParaRPr lang="en-US" sz="1200" dirty="0"/>
           </a:p>
@@ -5057,7 +5057,7 @@
                 <a:ea typeface="Malgun Gothic" pitchFamily="34" charset="-122"/>
                 <a:cs typeface="Malgun Gothic" pitchFamily="34" charset="-120"/>
               </a:rPr>
-              <a:t>______</a:t>
+              <a:t>김다빈</a:t>
             </a:r>
             <a:endParaRPr lang="en-US" sz="1200" dirty="0"/>
           </a:p>
@@ -5201,7 +5201,7 @@
                 <a:ea typeface="Malgun Gothic" pitchFamily="34" charset="-122"/>
                 <a:cs typeface="Malgun Gothic" pitchFamily="34" charset="-120"/>
               </a:rPr>
-              <a:t>______</a:t>
+              <a:t>김진아</a:t>
             </a:r>
             <a:endParaRPr lang="en-US" sz="1200" dirty="0"/>
           </a:p>
@@ -5345,7 +5345,7 @@
                 <a:ea typeface="Malgun Gothic" pitchFamily="34" charset="-122"/>
                 <a:cs typeface="Malgun Gothic" pitchFamily="34" charset="-120"/>
               </a:rPr>
-              <a:t>______</a:t>
+              <a:t>이승민</a:t>
             </a:r>
             <a:endParaRPr lang="en-US" sz="1200" dirty="0"/>
           </a:p>

</xml_diff>